<commit_message>
Add real screenshots to branch training deck (slides 2, 5, 6, 7, 8)
Co-Authored-By: Claude Opus 5.5 <noreply@anthropic.com>
Claude-Session: https://claude.ai/code/session_01LHLFw2GTW6okWXxcJBSwir
</commit_message>
<xml_diff>
--- a/presentation/SPAR_Branch_User_Training_Deck.pptx
+++ b/presentation/SPAR_Branch_User_Training_Deck.pptx
@@ -123,19 +123,19 @@
   <p:extLst>
     <p:ext uri="{521415D9-36F7-43E2-AB2F-B90AF26B5E84}">
       <p14:sectionLst xmlns:p14="http://schemas.microsoft.com/office/powerpoint/2010/main">
-        <p14:section name="Welcome" id="{de7892ea-274f-3657-19f4-017b52a0d41a}">
+        <p14:section name="Welcome" id="{ec85c069-b42f-58b1-2d6f-2b0c77638498}">
           <p14:sldIdLst>
             <p14:sldId id="256"/>
             <p14:sldId id="257"/>
             <p14:sldId id="258"/>
           </p14:sldIdLst>
         </p14:section>
-        <p14:section name="Your Role" id="{8378abc9-eb2c-1935-3a8f-56eaf6fc9cc4}">
+        <p14:section name="Your Role" id="{11028bee-5390-2f6d-b201-9209e558201e}">
           <p14:sldIdLst>
             <p14:sldId id="259"/>
           </p14:sldIdLst>
         </p14:section>
-        <p14:section name="Key Features" id="{c38e1720-cba9-be9a-6fd9-9893c1e1f6d0}">
+        <p14:section name="Key Features" id="{3dda3b4e-991a-0cae-7f84-9ee15d2f0f83}">
           <p14:sldIdLst>
             <p14:sldId id="260"/>
             <p14:sldId id="261"/>
@@ -148,7 +148,7 @@
             <p14:sldId id="268"/>
           </p14:sldIdLst>
         </p14:section>
-        <p14:section name="Wrap-up" id="{6383c9ba-e7c2-93d6-45bc-fed628be4db3}">
+        <p14:section name="Wrap-up" id="{8f4ac1de-82ac-7e0e-67ff-25e55de046ea}">
           <p14:sldIdLst>
             <p14:sldId id="269"/>
             <p14:sldId id="270"/>
@@ -11043,38 +11043,9 @@
           </a:p>
         </p:txBody>
       </p:sp>
-      <p:sp>
-        <p:nvSpPr>
-          <p:cNvPr id="18" name="Screenshot placeholder"/>
-          <p:cNvSpPr/>
-          <p:nvPr/>
-        </p:nvSpPr>
-        <p:spPr>
-          <a:xfrm>
-            <a:off x="7040880" y="1508760"/>
-            <a:ext cx="4599432" cy="3886200"/>
-          </a:xfrm>
-          <a:prstGeom prst="roundRect">
-            <a:avLst>
-              <a:gd name="adj" fmla="val 2824"/>
-            </a:avLst>
-          </a:prstGeom>
-          <a:solidFill>
-            <a:schemeClr val="tx2">
-              <a:alpha val="65000"/>
-            </a:schemeClr>
-          </a:solidFill>
-          <a:ln w="15875">
-            <a:solidFill>
-              <a:schemeClr val="accent1"/>
-            </a:solidFill>
-            <a:prstDash val="dash"/>
-          </a:ln>
-        </p:spPr>
-      </p:sp>
       <p:pic>
         <p:nvPicPr>
-          <p:cNvPr id="19" name="Screenshot icon" descr="preencoded.png">    </p:cNvPr>
+          <p:cNvPr id="18" name="Screenshot: SPAR Fresh Procurement sign-in screen" descr="SPAR Fresh Procurement sign-in screen">    </p:cNvPr>
           <p:cNvPicPr>
             <a:picLocks noChangeAspect="1"/>
           </p:cNvPicPr>
@@ -11088,8 +11059,8 @@
         </p:blipFill>
         <p:spPr>
           <a:xfrm>
-            <a:off x="9066276" y="2811780"/>
-            <a:ext cx="548640" cy="548640"/>
+            <a:off x="7040880" y="1508760"/>
+            <a:ext cx="4599432" cy="3886200"/>
           </a:xfrm>
           <a:prstGeom prst="rect">
             <a:avLst/>
@@ -11098,59 +11069,25 @@
       </p:pic>
       <p:sp>
         <p:nvSpPr>
-          <p:cNvPr id="20" name="Screenshot label"/>
-          <p:cNvSpPr txBox="1"/>
-          <p:nvPr/>
-        </p:nvSpPr>
-        <p:spPr>
-          <a:xfrm>
-            <a:off x="7315200" y="3497580"/>
-            <a:ext cx="4050792" cy="822960"/>
-          </a:xfrm>
-          <a:prstGeom prst="rect">
-            <a:avLst/>
-          </a:prstGeom>
-          <a:noFill/>
-          <a:ln/>
-        </p:spPr>
-        <p:txBody>
-          <a:bodyPr wrap="square" lIns="0" tIns="0" rIns="0" bIns="0" rtlCol="0" anchor="t"/>
-          <a:lstStyle/>
-          <a:p>
-            <a:pPr algn="ctr" indent="0" marL="0">
-              <a:spcAft>
-                <a:spcPts val="400"/>
-              </a:spcAft>
-              <a:buNone/>
-            </a:pPr>
-            <a:r>
-              <a:rPr lang="en-US" sz="1300" b="1" dirty="0">
-                <a:solidFill>
-                  <a:schemeClr val="bg2"/>
-                </a:solidFill>
-              </a:rPr>
-              <a:t>Insert screenshot</a:t>
-            </a:r>
-            <a:endParaRPr lang="en-US" sz="1300" dirty="0"/>
-          </a:p>
-          <a:p>
-            <a:pPr algn="ctr" indent="0" marL="0">
-              <a:spcAft>
-                <a:spcPts val="400"/>
-              </a:spcAft>
-              <a:buNone/>
-            </a:pPr>
-            <a:r>
-              <a:rPr lang="en-US" sz="1300" dirty="0">
-                <a:solidFill>
-                  <a:schemeClr val="bg2"/>
-                </a:solidFill>
-              </a:rPr>
-              <a:t>Branch Dashboard home screen</a:t>
-            </a:r>
-            <a:endParaRPr lang="en-US" sz="1300" dirty="0"/>
-          </a:p>
-        </p:txBody>
+          <p:cNvPr id="19" name="Screenshot frame"/>
+          <p:cNvSpPr/>
+          <p:nvPr/>
+        </p:nvSpPr>
+        <p:spPr>
+          <a:xfrm>
+            <a:off x="7040880" y="1508760"/>
+            <a:ext cx="4599432" cy="3886200"/>
+          </a:xfrm>
+          <a:prstGeom prst="rect">
+            <a:avLst/>
+          </a:prstGeom>
+          <a:ln w="19050">
+            <a:solidFill>
+              <a:schemeClr val="accent1"/>
+            </a:solidFill>
+            <a:prstDash val="solid"/>
+          </a:ln>
+        </p:spPr>
       </p:sp>
       <p:sp>
         <p:nvSpPr>
@@ -13891,38 +13828,9 @@
           </a:p>
         </p:txBody>
       </p:sp>
-      <p:sp>
-        <p:nvSpPr>
-          <p:cNvPr id="31" name="Screenshot placeholder"/>
-          <p:cNvSpPr/>
-          <p:nvPr/>
-        </p:nvSpPr>
-        <p:spPr>
-          <a:xfrm>
-            <a:off x="7406640" y="1783080"/>
-            <a:ext cx="4233672" cy="3538728"/>
-          </a:xfrm>
-          <a:prstGeom prst="roundRect">
-            <a:avLst>
-              <a:gd name="adj" fmla="val 3101"/>
-            </a:avLst>
-          </a:prstGeom>
-          <a:solidFill>
-            <a:schemeClr val="tx2">
-              <a:alpha val="65000"/>
-            </a:schemeClr>
-          </a:solidFill>
-          <a:ln w="15875">
-            <a:solidFill>
-              <a:schemeClr val="accent1"/>
-            </a:solidFill>
-            <a:prstDash val="dash"/>
-          </a:ln>
-        </p:spPr>
-      </p:sp>
       <p:pic>
         <p:nvPicPr>
-          <p:cNvPr id="32" name="Screenshot icon" descr="preencoded.png">    </p:cNvPr>
+          <p:cNvPr id="31" name="Screenshot: Branch Dashboard with the six tabs" descr="Branch Dashboard with the six tabs">    </p:cNvPr>
           <p:cNvPicPr>
             <a:picLocks noChangeAspect="1"/>
           </p:cNvPicPr>
@@ -13936,8 +13844,8 @@
         </p:blipFill>
         <p:spPr>
           <a:xfrm>
-            <a:off x="9249156" y="2912364"/>
-            <a:ext cx="548640" cy="548640"/>
+            <a:off x="7406640" y="1783080"/>
+            <a:ext cx="4233672" cy="3538728"/>
           </a:xfrm>
           <a:prstGeom prst="rect">
             <a:avLst/>
@@ -13946,63 +13854,29 @@
       </p:pic>
       <p:sp>
         <p:nvSpPr>
-          <p:cNvPr id="33" name="Screenshot label"/>
-          <p:cNvSpPr txBox="1"/>
-          <p:nvPr/>
-        </p:nvSpPr>
-        <p:spPr>
-          <a:xfrm>
-            <a:off x="7680960" y="3598164"/>
-            <a:ext cx="3685032" cy="822960"/>
-          </a:xfrm>
-          <a:prstGeom prst="rect">
-            <a:avLst/>
-          </a:prstGeom>
-          <a:noFill/>
-          <a:ln/>
-        </p:spPr>
-        <p:txBody>
-          <a:bodyPr wrap="square" lIns="0" tIns="0" rIns="0" bIns="0" rtlCol="0" anchor="t"/>
-          <a:lstStyle/>
-          <a:p>
-            <a:pPr algn="ctr" indent="0" marL="0">
-              <a:spcAft>
-                <a:spcPts val="400"/>
-              </a:spcAft>
-              <a:buNone/>
-            </a:pPr>
-            <a:r>
-              <a:rPr lang="en-US" sz="1300" b="1" dirty="0">
-                <a:solidFill>
-                  <a:schemeClr val="bg2"/>
-                </a:solidFill>
-              </a:rPr>
-              <a:t>Insert screenshot</a:t>
-            </a:r>
-            <a:endParaRPr lang="en-US" sz="1300" dirty="0"/>
-          </a:p>
-          <a:p>
-            <a:pPr algn="ctr" indent="0" marL="0">
-              <a:spcAft>
-                <a:spcPts val="400"/>
-              </a:spcAft>
-              <a:buNone/>
-            </a:pPr>
-            <a:r>
-              <a:rPr lang="en-US" sz="1300" dirty="0">
-                <a:solidFill>
-                  <a:schemeClr val="bg2"/>
-                </a:solidFill>
-              </a:rPr>
-              <a:t>Branch Dashboard with the six tabs labelled</a:t>
-            </a:r>
-            <a:endParaRPr lang="en-US" sz="1300" dirty="0"/>
-          </a:p>
-        </p:txBody>
-      </p:sp>
-      <p:sp>
-        <p:nvSpPr>
-          <p:cNvPr id="34" name="Benefit pill"/>
+          <p:cNvPr id="32" name="Screenshot frame"/>
+          <p:cNvSpPr/>
+          <p:nvPr/>
+        </p:nvSpPr>
+        <p:spPr>
+          <a:xfrm>
+            <a:off x="7406640" y="1783080"/>
+            <a:ext cx="4233672" cy="3538728"/>
+          </a:xfrm>
+          <a:prstGeom prst="rect">
+            <a:avLst/>
+          </a:prstGeom>
+          <a:ln w="19050">
+            <a:solidFill>
+              <a:schemeClr val="accent1"/>
+            </a:solidFill>
+            <a:prstDash val="solid"/>
+          </a:ln>
+        </p:spPr>
+      </p:sp>
+      <p:sp>
+        <p:nvSpPr>
+          <p:cNvPr id="33" name="Benefit pill"/>
           <p:cNvSpPr/>
           <p:nvPr/>
         </p:nvSpPr>
@@ -14031,7 +13905,7 @@
       </p:sp>
       <p:pic>
         <p:nvPicPr>
-          <p:cNvPr id="35" name="Benefit icon" descr="preencoded.png">    </p:cNvPr>
+          <p:cNvPr id="34" name="Benefit icon" descr="preencoded.png">    </p:cNvPr>
           <p:cNvPicPr>
             <a:picLocks noChangeAspect="1"/>
           </p:cNvPicPr>
@@ -14055,7 +13929,7 @@
       </p:pic>
       <p:sp>
         <p:nvSpPr>
-          <p:cNvPr id="36" name="Text 25"/>
+          <p:cNvPr id="35" name="Text 24"/>
           <p:cNvSpPr txBox="1"/>
           <p:nvPr/>
         </p:nvSpPr>
@@ -14428,7 +14302,7 @@
         <p:spPr>
           <a:xfrm>
             <a:off x="1463040" y="1481328"/>
-            <a:ext cx="5394960" cy="868680"/>
+            <a:ext cx="4434840" cy="914400"/>
           </a:xfrm>
           <a:prstGeom prst="rect">
             <a:avLst/>
@@ -14535,7 +14409,7 @@
         <p:spPr>
           <a:xfrm>
             <a:off x="1463040" y="2468880"/>
-            <a:ext cx="5394960" cy="868680"/>
+            <a:ext cx="4434840" cy="914400"/>
           </a:xfrm>
           <a:prstGeom prst="rect">
             <a:avLst/>
@@ -14642,7 +14516,7 @@
         <p:spPr>
           <a:xfrm>
             <a:off x="1463040" y="3456432"/>
-            <a:ext cx="5394960" cy="868680"/>
+            <a:ext cx="4434840" cy="914400"/>
           </a:xfrm>
           <a:prstGeom prst="rect">
             <a:avLst/>
@@ -14749,7 +14623,7 @@
         <p:spPr>
           <a:xfrm>
             <a:off x="1463040" y="4443984"/>
-            <a:ext cx="5394960" cy="868680"/>
+            <a:ext cx="4434840" cy="914400"/>
           </a:xfrm>
           <a:prstGeom prst="rect">
             <a:avLst/>
@@ -14796,38 +14670,9 @@
           </a:p>
         </p:txBody>
       </p:sp>
-      <p:sp>
-        <p:nvSpPr>
-          <p:cNvPr id="18" name="Screenshot placeholder"/>
-          <p:cNvSpPr/>
-          <p:nvPr/>
-        </p:nvSpPr>
-        <p:spPr>
-          <a:xfrm>
-            <a:off x="7040880" y="1463040"/>
-            <a:ext cx="4599432" cy="3840480"/>
-          </a:xfrm>
-          <a:prstGeom prst="roundRect">
-            <a:avLst>
-              <a:gd name="adj" fmla="val 2857"/>
-            </a:avLst>
-          </a:prstGeom>
-          <a:solidFill>
-            <a:schemeClr val="tx2">
-              <a:alpha val="65000"/>
-            </a:schemeClr>
-          </a:solidFill>
-          <a:ln w="15875">
-            <a:solidFill>
-              <a:schemeClr val="accent1"/>
-            </a:solidFill>
-            <a:prstDash val="dash"/>
-          </a:ln>
-        </p:spPr>
-      </p:sp>
       <p:pic>
         <p:nvPicPr>
-          <p:cNvPr id="19" name="Screenshot icon" descr="preencoded.png">    </p:cNvPr>
+          <p:cNvPr id="18" name="Screenshot: Product list with promotion badges and Stock in Hand" descr="Product list with promotion badges and Stock in Hand">    </p:cNvPr>
           <p:cNvPicPr>
             <a:picLocks noChangeAspect="1"/>
           </p:cNvPicPr>
@@ -14841,8 +14686,8 @@
         </p:blipFill>
         <p:spPr>
           <a:xfrm>
-            <a:off x="9066276" y="2743200"/>
-            <a:ext cx="548640" cy="548640"/>
+            <a:off x="6153912" y="1463040"/>
+            <a:ext cx="5486400" cy="3840480"/>
           </a:xfrm>
           <a:prstGeom prst="rect">
             <a:avLst/>
@@ -14851,63 +14696,29 @@
       </p:pic>
       <p:sp>
         <p:nvSpPr>
-          <p:cNvPr id="20" name="Screenshot label"/>
-          <p:cNvSpPr txBox="1"/>
-          <p:nvPr/>
-        </p:nvSpPr>
-        <p:spPr>
-          <a:xfrm>
-            <a:off x="7315200" y="3429000"/>
-            <a:ext cx="4050792" cy="822960"/>
-          </a:xfrm>
-          <a:prstGeom prst="rect">
-            <a:avLst/>
-          </a:prstGeom>
-          <a:noFill/>
-          <a:ln/>
-        </p:spPr>
-        <p:txBody>
-          <a:bodyPr wrap="square" lIns="0" tIns="0" rIns="0" bIns="0" rtlCol="0" anchor="t"/>
-          <a:lstStyle/>
-          <a:p>
-            <a:pPr algn="ctr" indent="0" marL="0">
-              <a:spcAft>
-                <a:spcPts val="400"/>
-              </a:spcAft>
-              <a:buNone/>
-            </a:pPr>
-            <a:r>
-              <a:rPr lang="en-US" sz="1300" b="1" dirty="0">
-                <a:solidFill>
-                  <a:schemeClr val="bg2"/>
-                </a:solidFill>
-              </a:rPr>
-              <a:t>Insert screenshot</a:t>
-            </a:r>
-            <a:endParaRPr lang="en-US" sz="1300" dirty="0"/>
-          </a:p>
-          <a:p>
-            <a:pPr algn="ctr" indent="0" marL="0">
-              <a:spcAft>
-                <a:spcPts val="400"/>
-              </a:spcAft>
-              <a:buNone/>
-            </a:pPr>
-            <a:r>
-              <a:rPr lang="en-US" sz="1300" dirty="0">
-                <a:solidFill>
-                  <a:schemeClr val="bg2"/>
-                </a:solidFill>
-              </a:rPr>
-              <a:t>Product list: search, category filter, Stock in Hand, promotion badge</a:t>
-            </a:r>
-            <a:endParaRPr lang="en-US" sz="1300" dirty="0"/>
-          </a:p>
-        </p:txBody>
-      </p:sp>
-      <p:sp>
-        <p:nvSpPr>
-          <p:cNvPr id="21" name="Benefit pill"/>
+          <p:cNvPr id="19" name="Screenshot frame"/>
+          <p:cNvSpPr/>
+          <p:nvPr/>
+        </p:nvSpPr>
+        <p:spPr>
+          <a:xfrm>
+            <a:off x="6153912" y="1463040"/>
+            <a:ext cx="5486400" cy="3840480"/>
+          </a:xfrm>
+          <a:prstGeom prst="rect">
+            <a:avLst/>
+          </a:prstGeom>
+          <a:ln w="19050">
+            <a:solidFill>
+              <a:schemeClr val="accent1"/>
+            </a:solidFill>
+            <a:prstDash val="solid"/>
+          </a:ln>
+        </p:spPr>
+      </p:sp>
+      <p:sp>
+        <p:nvSpPr>
+          <p:cNvPr id="20" name="Benefit pill"/>
           <p:cNvSpPr/>
           <p:nvPr/>
         </p:nvSpPr>
@@ -14936,7 +14747,7 @@
       </p:sp>
       <p:pic>
         <p:nvPicPr>
-          <p:cNvPr id="22" name="Benefit icon" descr="preencoded.png">    </p:cNvPr>
+          <p:cNvPr id="21" name="Benefit icon" descr="preencoded.png">    </p:cNvPr>
           <p:cNvPicPr>
             <a:picLocks noChangeAspect="1"/>
           </p:cNvPicPr>
@@ -14960,7 +14771,7 @@
       </p:pic>
       <p:sp>
         <p:nvSpPr>
-          <p:cNvPr id="23" name="Text 14"/>
+          <p:cNvPr id="22" name="Text 13"/>
           <p:cNvSpPr txBox="1"/>
           <p:nvPr/>
         </p:nvSpPr>
@@ -15905,38 +15716,9 @@
           </a:p>
         </p:txBody>
       </p:sp>
-      <p:sp>
-        <p:nvSpPr>
-          <p:cNvPr id="22" name="Screenshot placeholder"/>
-          <p:cNvSpPr/>
-          <p:nvPr/>
-        </p:nvSpPr>
-        <p:spPr>
-          <a:xfrm>
-            <a:off x="6812280" y="3840480"/>
-            <a:ext cx="4828032" cy="1554480"/>
-          </a:xfrm>
-          <a:prstGeom prst="roundRect">
-            <a:avLst>
-              <a:gd name="adj" fmla="val 7059"/>
-            </a:avLst>
-          </a:prstGeom>
-          <a:solidFill>
-            <a:schemeClr val="tx2">
-              <a:alpha val="65000"/>
-            </a:schemeClr>
-          </a:solidFill>
-          <a:ln w="15875">
-            <a:solidFill>
-              <a:schemeClr val="accent1"/>
-            </a:solidFill>
-            <a:prstDash val="dash"/>
-          </a:ln>
-        </p:spPr>
-      </p:sp>
       <p:pic>
         <p:nvPicPr>
-          <p:cNvPr id="23" name="Screenshot icon" descr="preencoded.png">    </p:cNvPr>
+          <p:cNvPr id="22" name="Screenshot: Order form with quantities, Save Order and Submit Order" descr="Order form with quantities, Save Order and Submit Order">    </p:cNvPr>
           <p:cNvPicPr>
             <a:picLocks noChangeAspect="1"/>
           </p:cNvPicPr>
@@ -15950,8 +15732,8 @@
         </p:blipFill>
         <p:spPr>
           <a:xfrm>
-            <a:off x="8951976" y="3977640"/>
-            <a:ext cx="548640" cy="548640"/>
+            <a:off x="6812280" y="3840480"/>
+            <a:ext cx="4828032" cy="1554480"/>
           </a:xfrm>
           <a:prstGeom prst="rect">
             <a:avLst/>
@@ -15960,63 +15742,29 @@
       </p:pic>
       <p:sp>
         <p:nvSpPr>
-          <p:cNvPr id="24" name="Screenshot label"/>
-          <p:cNvSpPr txBox="1"/>
-          <p:nvPr/>
-        </p:nvSpPr>
-        <p:spPr>
-          <a:xfrm>
-            <a:off x="7086600" y="4663440"/>
-            <a:ext cx="4279392" cy="822960"/>
-          </a:xfrm>
-          <a:prstGeom prst="rect">
-            <a:avLst/>
-          </a:prstGeom>
-          <a:noFill/>
-          <a:ln/>
-        </p:spPr>
-        <p:txBody>
-          <a:bodyPr wrap="square" lIns="0" tIns="0" rIns="0" bIns="0" rtlCol="0" anchor="t"/>
-          <a:lstStyle/>
-          <a:p>
-            <a:pPr algn="ctr" indent="0" marL="0">
-              <a:spcAft>
-                <a:spcPts val="400"/>
-              </a:spcAft>
-              <a:buNone/>
-            </a:pPr>
-            <a:r>
-              <a:rPr lang="en-US" sz="1300" b="1" dirty="0">
-                <a:solidFill>
-                  <a:schemeClr val="bg2"/>
-                </a:solidFill>
-              </a:rPr>
-              <a:t>Insert screenshot</a:t>
-            </a:r>
-            <a:endParaRPr lang="en-US" sz="1300" dirty="0"/>
-          </a:p>
-          <a:p>
-            <a:pPr algn="ctr" indent="0" marL="0">
-              <a:spcAft>
-                <a:spcPts val="400"/>
-              </a:spcAft>
-              <a:buNone/>
-            </a:pPr>
-            <a:r>
-              <a:rPr lang="en-US" sz="1300" dirty="0">
-                <a:solidFill>
-                  <a:schemeClr val="bg2"/>
-                </a:solidFill>
-              </a:rPr>
-              <a:t>Order form with Save Order / Submit Order</a:t>
-            </a:r>
-            <a:endParaRPr lang="en-US" sz="1300" dirty="0"/>
-          </a:p>
-        </p:txBody>
-      </p:sp>
-      <p:sp>
-        <p:nvSpPr>
-          <p:cNvPr id="25" name="Benefit pill"/>
+          <p:cNvPr id="23" name="Screenshot frame"/>
+          <p:cNvSpPr/>
+          <p:nvPr/>
+        </p:nvSpPr>
+        <p:spPr>
+          <a:xfrm>
+            <a:off x="6812280" y="3840480"/>
+            <a:ext cx="4828032" cy="1554480"/>
+          </a:xfrm>
+          <a:prstGeom prst="rect">
+            <a:avLst/>
+          </a:prstGeom>
+          <a:ln w="19050">
+            <a:solidFill>
+              <a:schemeClr val="accent1"/>
+            </a:solidFill>
+            <a:prstDash val="solid"/>
+          </a:ln>
+        </p:spPr>
+      </p:sp>
+      <p:sp>
+        <p:nvSpPr>
+          <p:cNvPr id="24" name="Benefit pill"/>
           <p:cNvSpPr/>
           <p:nvPr/>
         </p:nvSpPr>
@@ -16045,7 +15793,7 @@
       </p:sp>
       <p:pic>
         <p:nvPicPr>
-          <p:cNvPr id="26" name="Benefit icon" descr="preencoded.png">    </p:cNvPr>
+          <p:cNvPr id="25" name="Benefit icon" descr="preencoded.png">    </p:cNvPr>
           <p:cNvPicPr>
             <a:picLocks noChangeAspect="1"/>
           </p:cNvPicPr>
@@ -16069,7 +15817,7 @@
       </p:pic>
       <p:sp>
         <p:nvSpPr>
-          <p:cNvPr id="27" name="Text 21"/>
+          <p:cNvPr id="26" name="Text 20"/>
           <p:cNvSpPr txBox="1"/>
           <p:nvPr/>
         </p:nvSpPr>
@@ -17025,38 +16773,9 @@
           </a:p>
         </p:txBody>
       </p:sp>
-      <p:sp>
-        <p:nvSpPr>
-          <p:cNvPr id="26" name="Screenshot placeholder"/>
-          <p:cNvSpPr/>
-          <p:nvPr/>
-        </p:nvSpPr>
-        <p:spPr>
-          <a:xfrm>
-            <a:off x="6812280" y="4206240"/>
-            <a:ext cx="4828032" cy="1188720"/>
-          </a:xfrm>
-          <a:prstGeom prst="roundRect">
-            <a:avLst>
-              <a:gd name="adj" fmla="val 9231"/>
-            </a:avLst>
-          </a:prstGeom>
-          <a:solidFill>
-            <a:schemeClr val="tx2">
-              <a:alpha val="65000"/>
-            </a:schemeClr>
-          </a:solidFill>
-          <a:ln w="15875">
-            <a:solidFill>
-              <a:schemeClr val="accent1"/>
-            </a:solidFill>
-            <a:prstDash val="dash"/>
-          </a:ln>
-        </p:spPr>
-      </p:sp>
       <p:pic>
         <p:nvPicPr>
-          <p:cNvPr id="27" name="Screenshot icon" descr="preencoded.png">    </p:cNvPr>
+          <p:cNvPr id="26" name="Screenshot: Auto-submitted orders as head office sees them" descr="Auto-submitted orders as head office sees them">    </p:cNvPr>
           <p:cNvPicPr>
             <a:picLocks noChangeAspect="1"/>
           </p:cNvPicPr>
@@ -17070,8 +16789,8 @@
         </p:blipFill>
         <p:spPr>
           <a:xfrm>
-            <a:off x="8951976" y="4160520"/>
-            <a:ext cx="548640" cy="548640"/>
+            <a:off x="6812280" y="4206240"/>
+            <a:ext cx="4828032" cy="1188720"/>
           </a:xfrm>
           <a:prstGeom prst="rect">
             <a:avLst/>
@@ -17080,63 +16799,29 @@
       </p:pic>
       <p:sp>
         <p:nvSpPr>
-          <p:cNvPr id="28" name="Screenshot label"/>
-          <p:cNvSpPr txBox="1"/>
-          <p:nvPr/>
-        </p:nvSpPr>
-        <p:spPr>
-          <a:xfrm>
-            <a:off x="7086600" y="4846320"/>
-            <a:ext cx="4279392" cy="822960"/>
-          </a:xfrm>
-          <a:prstGeom prst="rect">
-            <a:avLst/>
-          </a:prstGeom>
-          <a:noFill/>
-          <a:ln/>
-        </p:spPr>
-        <p:txBody>
-          <a:bodyPr wrap="square" lIns="0" tIns="0" rIns="0" bIns="0" rtlCol="0" anchor="t"/>
-          <a:lstStyle/>
-          <a:p>
-            <a:pPr algn="ctr" indent="0" marL="0">
-              <a:spcAft>
-                <a:spcPts val="400"/>
-              </a:spcAft>
-              <a:buNone/>
-            </a:pPr>
-            <a:r>
-              <a:rPr lang="en-US" sz="1300" b="1" dirty="0">
-                <a:solidFill>
-                  <a:schemeClr val="bg2"/>
-                </a:solidFill>
-              </a:rPr>
-              <a:t>Insert screenshot</a:t>
-            </a:r>
-            <a:endParaRPr lang="en-US" sz="1300" dirty="0"/>
-          </a:p>
-          <a:p>
-            <a:pPr algn="ctr" indent="0" marL="0">
-              <a:spcAft>
-                <a:spcPts val="400"/>
-              </a:spcAft>
-              <a:buNone/>
-            </a:pPr>
-            <a:r>
-              <a:rPr lang="en-US" sz="1300" dirty="0">
-                <a:solidFill>
-                  <a:schemeClr val="bg2"/>
-                </a:solidFill>
-              </a:rPr>
-              <a:t>"Your order was submitted automatically" message</a:t>
-            </a:r>
-            <a:endParaRPr lang="en-US" sz="1300" dirty="0"/>
-          </a:p>
-        </p:txBody>
-      </p:sp>
-      <p:sp>
-        <p:nvSpPr>
-          <p:cNvPr id="29" name="Benefit pill"/>
+          <p:cNvPr id="27" name="Screenshot frame"/>
+          <p:cNvSpPr/>
+          <p:nvPr/>
+        </p:nvSpPr>
+        <p:spPr>
+          <a:xfrm>
+            <a:off x="6812280" y="4206240"/>
+            <a:ext cx="4828032" cy="1188720"/>
+          </a:xfrm>
+          <a:prstGeom prst="rect">
+            <a:avLst/>
+          </a:prstGeom>
+          <a:ln w="19050">
+            <a:solidFill>
+              <a:schemeClr val="accent1"/>
+            </a:solidFill>
+            <a:prstDash val="solid"/>
+          </a:ln>
+        </p:spPr>
+      </p:sp>
+      <p:sp>
+        <p:nvSpPr>
+          <p:cNvPr id="28" name="Benefit pill"/>
           <p:cNvSpPr/>
           <p:nvPr/>
         </p:nvSpPr>
@@ -17165,7 +16850,7 @@
       </p:sp>
       <p:pic>
         <p:nvPicPr>
-          <p:cNvPr id="30" name="Benefit icon" descr="preencoded.png">    </p:cNvPr>
+          <p:cNvPr id="29" name="Benefit icon" descr="preencoded.png">    </p:cNvPr>
           <p:cNvPicPr>
             <a:picLocks noChangeAspect="1"/>
           </p:cNvPicPr>
@@ -17189,7 +16874,7 @@
       </p:pic>
       <p:sp>
         <p:nvSpPr>
-          <p:cNvPr id="31" name="Text 23"/>
+          <p:cNvPr id="30" name="Text 22"/>
           <p:cNvSpPr txBox="1"/>
           <p:nvPr/>
         </p:nvSpPr>

</xml_diff>